<commit_message>
Regenerate results from two new runs and update verification
</commit_message>
<xml_diff>
--- a/reports/presentation/retention-deck.pptx
+++ b/reports/presentation/retention-deck.pptx
@@ -724,7 +724,7 @@
           <a:lstStyle/>
           <a:p>
             <a:r>
-              <a:t>Randomising inside the target list gives the causal effect we could not estimate from the data. Each offer is its own arm. Measured save rates replace assumptions in the configuration and the whole analysis re-runs.</a:t>
+              <a:t>The wave is the recommended list scaled to the 7,043-customer base (22% of customers). Randomising inside the target list gives the causal effect we could not estimate from the data. Each offer is its own arm. Measured save rates replace assumptions in the configuration and the whole analysis re-runs.</a:t>
             </a:r>
           </a:p>
         </p:txBody>
@@ -794,7 +794,7 @@
           <a:lstStyle/>
           <a:p>
             <a:r>
-              <a:t>Close with the ask. Then switch to the dashboard demo: change the save rate and budget, show the KPIs and the action list update, export the campaign file with its scenario ID.</a:t>
+              <a:t>Close with the ask. If the true save rate is 20%, the rule says go after one wave 94% of the time; the significance test protects against acting on noise, the break-even test protects the budget. Then switch to the dashboard demo: change the save rate and budget, show the KPIs and the action list update, export the campaign file with its scenario ID.</a:t>
             </a:r>
           </a:p>
         </p:txBody>
@@ -1214,7 +1214,7 @@
           <a:lstStyle/>
           <a:p>
             <a:r>
-              <a:t>Same customers, same budget, same assumptions. Risk-only has higher precision but lower value. Segment offers add $290 only under assumed save rates; with actual outcomes that extra gain is not distinguishable from zero, so the pilot must test offers.</a:t>
+              <a:t>Same customers, same budget, same assumptions. Precision is the share of contacted customers who actually churned; HR/HV coverage is the share of high-risk, high-value customers reached. Risk-only has higher precision but lower value. Segment offers add $290 only under assumed save rates; with actual outcomes that extra gain is not distinguishable from zero, so the pilot must test offers.</a:t>
             </a:r>
           </a:p>
         </p:txBody>
@@ -1284,7 +1284,7 @@
           <a:lstStyle/>
           <a:p>
             <a:r>
-              <a:t>Each extra step of budget reaches customers with lower expected value. Beyond about 27% of customers nobody has positive expected value, so spending more destroys value.</a:t>
+              <a:t>The x-axis is the budget as the share of customers the standard offer could reach; the recommended budget equals the standard offer for 24% of customers, about $42,238 for the whole base. Each extra step reaches customers with lower expected value. Beyond 27% of customers contacted nobody has positive expected value, so spending more destroys value.</a:t>
             </a:r>
           </a:p>
         </p:txBody>
@@ -5145,7 +5145,7 @@
                 </a:solidFill>
                 <a:latin typeface="Segoe UI"/>
               </a:rPr>
-              <a:t>• One wave: 1,690 customers, 845 offered, 845 held out at random</a:t>
+              <a:t>• One wave: 1,550 customers, 775 offered, 775 held out at random</a:t>
             </a:r>
           </a:p>
           <a:p>
@@ -5177,7 +5177,7 @@
                 </a:solidFill>
                 <a:latin typeface="Segoe UI"/>
               </a:rPr>
-              <a:t>• Detects a save rate of about 11% or more in one wave</a:t>
+              <a:t>• Detects a save rate of about 12% or more in one wave; break-even is 13.9%</a:t>
             </a:r>
           </a:p>
           <a:p>
@@ -5193,7 +5193,7 @@
                 </a:solidFill>
                 <a:latin typeface="Segoe UI"/>
               </a:rPr>
-              <a:t>• Offer and contact cost about $23,033</a:t>
+              <a:t>• Offer and contact cost about $21,125</a:t>
             </a:r>
           </a:p>
         </p:txBody>
@@ -5361,7 +5361,7 @@
                 </a:solidFill>
                 <a:latin typeface="Segoe UI"/>
               </a:rPr>
-              <a:t>• Approve one pilot wave sized at 24% of the base, half held out</a:t>
+              <a:t>• Approve one pilot wave: 1,550 customers, half held out, about $21,125</a:t>
             </a:r>
           </a:p>
           <a:p>
@@ -5393,7 +5393,7 @@
                 </a:solidFill>
                 <a:latin typeface="Segoe UI"/>
               </a:rPr>
-              <a:t>• Agree the go rule now: scale only if the save rate's lower 95% bound is above 11.8%</a:t>
+              <a:t>• Agree the rule now: go if the effect is significant and at least 13.9%; else stop or extend</a:t>
             </a:r>
           </a:p>
           <a:p>
@@ -6789,11 +6789,12 @@
                 <a:tableStyleId>{5C22544A-7EE6-4342-B048-85BDC9FD1C3A}</a:tableStyleId>
               </a:tblPr>
               <a:tblGrid>
-                <a:gridCol w="2231136"/>
-                <a:gridCol w="2231136"/>
-                <a:gridCol w="2231136"/>
-                <a:gridCol w="2231136"/>
-                <a:gridCol w="2231136"/>
+                <a:gridCol w="1859280"/>
+                <a:gridCol w="1859280"/>
+                <a:gridCol w="1859280"/>
+                <a:gridCol w="1859280"/>
+                <a:gridCol w="1859280"/>
+                <a:gridCol w="1859280"/>
               </a:tblGrid>
               <a:tr h="384048">
                 <a:tc>
@@ -6863,6 +6864,24 @@
                           <a:latin typeface="Segoe UI"/>
                         </a:rPr>
                         <a:t>ROI</a:t>
+                      </a:r>
+                    </a:p>
+                  </a:txBody>
+                  <a:tcPr/>
+                </a:tc>
+                <a:tc>
+                  <a:txBody>
+                    <a:bodyPr/>
+                    <a:lstStyle/>
+                    <a:p>
+                      <a:r>
+                        <a:rPr sz="1200" b="1">
+                          <a:solidFill>
+                            <a:srgbClr val="FFFFFF"/>
+                          </a:solidFill>
+                          <a:latin typeface="Segoe UI"/>
+                        </a:rPr>
+                        <a:t>Precision</a:t>
                       </a:r>
                     </a:p>
                   </a:txBody>
@@ -6972,6 +6991,24 @@
                           </a:solidFill>
                           <a:latin typeface="Segoe UI"/>
                         </a:rPr>
+                        <a:t>70%</a:t>
+                      </a:r>
+                    </a:p>
+                  </a:txBody>
+                  <a:tcPr/>
+                </a:tc>
+                <a:tc>
+                  <a:txBody>
+                    <a:bodyPr/>
+                    <a:lstStyle/>
+                    <a:p>
+                      <a:r>
+                        <a:rPr sz="1200" b="0">
+                          <a:solidFill>
+                            <a:srgbClr val="0B0B0B"/>
+                          </a:solidFill>
+                          <a:latin typeface="Segoe UI"/>
+                        </a:rPr>
                         <a:t>4%</a:t>
                       </a:r>
                     </a:p>
@@ -7047,6 +7084,24 @@
                           <a:latin typeface="Segoe UI"/>
                         </a:rPr>
                         <a:t>61%</a:t>
+                      </a:r>
+                    </a:p>
+                  </a:txBody>
+                  <a:tcPr/>
+                </a:tc>
+                <a:tc>
+                  <a:txBody>
+                    <a:bodyPr/>
+                    <a:lstStyle/>
+                    <a:p>
+                      <a:r>
+                        <a:rPr sz="1200" b="0">
+                          <a:solidFill>
+                            <a:srgbClr val="0B0B0B"/>
+                          </a:solidFill>
+                          <a:latin typeface="Segoe UI"/>
+                        </a:rPr>
+                        <a:t>62%</a:t>
                       </a:r>
                     </a:p>
                   </a:txBody>
@@ -7156,6 +7211,24 @@
                           </a:solidFill>
                           <a:latin typeface="Segoe UI"/>
                         </a:rPr>
+                        <a:t>60%</a:t>
+                      </a:r>
+                    </a:p>
+                  </a:txBody>
+                  <a:tcPr/>
+                </a:tc>
+                <a:tc>
+                  <a:txBody>
+                    <a:bodyPr/>
+                    <a:lstStyle/>
+                    <a:p>
+                      <a:r>
+                        <a:rPr sz="1200" b="0">
+                          <a:solidFill>
+                            <a:srgbClr val="0B0B0B"/>
+                          </a:solidFill>
+                          <a:latin typeface="Segoe UI"/>
+                        </a:rPr>
                         <a:t>100%</a:t>
                       </a:r>
                     </a:p>
@@ -7330,7 +7403,7 @@
                 </a:solidFill>
                 <a:latin typeface="Segoe UI"/>
               </a:rPr>
-              <a:t>• Recommended: 24% of customers (chosen on validation)</a:t>
+              <a:t>• Recommended budget: $6.00 per customer in the base (chosen on validation)</a:t>
             </a:r>
           </a:p>
           <a:p>
@@ -7346,7 +7419,7 @@
                 </a:solidFill>
                 <a:latin typeface="Segoe UI"/>
               </a:rPr>
-              <a:t>• Test: 310 offers, $8,450, net $3,692 (ROI 44%)</a:t>
+              <a:t>• Test: 310 offers (22% of customers), $8,450, net $3,692 (ROI 44%)</a:t>
             </a:r>
           </a:p>
           <a:p>
@@ -7554,7 +7627,7 @@
                 </a:solidFill>
                 <a:latin typeface="Segoe UI"/>
               </a:rPr>
-              <a:t>• Break-even save rate 11.8% (assumed 20%)</a:t>
+              <a:t>• Break-even save rate 11.8% at the base budget, 13.9% at the recommended budget (assumed 20%)</a:t>
             </a:r>
           </a:p>
           <a:p>

</xml_diff>

<commit_message>
Regenerate results from two final runs and record verification
Runs A and B use the final code and configuration; older runs are
pruned. Reports, notebooks, figures, the two-page brief, the 14-slide
deck and dashboard screenshots come from run B. Tests, notebook,
release and browser checks pass; the verification record and change
log describe the 2.1.0 release.
</commit_message>
<xml_diff>
--- a/reports/presentation/retention-deck.pptx
+++ b/reports/presentation/retention-deck.pptx
@@ -18,6 +18,7 @@
     <p:sldId id="266" r:id="rId18"/>
     <p:sldId id="267" r:id="rId19"/>
     <p:sldId id="268" r:id="rId20"/>
+    <p:sldId id="269" r:id="rId21"/>
   </p:sldIdLst>
   <p:sldSz cx="12191695" cy="6858000" type="screen4x3"/>
   <p:notesSz cx="6858000" cy="9144000"/>
@@ -514,7 +515,7 @@
           <a:lstStyle/>
           <a:p>
             <a:r>
-              <a:t>Open with the decision, not the algorithm. We were asked how to spend a limited retention budget when both churn risk and customer value matter. In twelve minutes: the problem, the data, the model, the decision rule, the money, how robust it is, risks, and what we ask management to approve.</a:t>
+              <a:t>Open with the decision and the answer. The data are IBM's fictional US telco sample; every dollar figure belongs to that company. Agenda: summary, the problem in money, the model, the rule, who we target, value, budget, downside, outside the sample, fairness, the pilot, the ask, then a live demo.</a:t>
             </a:r>
           </a:p>
         </p:txBody>
@@ -584,7 +585,7 @@
           <a:lstStyle/>
           <a:p>
             <a:r>
-              <a:t>An offer is both a benefit (discount) and a burden (a call). We flag the senior gap for review rather than hide it. Contact cap, one retention contact per 30 days, and the Vietnamese legal call window protect experience.</a:t>
+              <a:t>Probabilities were shifted to lower average churn with the ranking unchanged. The Vietnam-like rows use a 250,000 VND home-fibre bill and an SMS of 500 VND. In Vietnam most mobile customers are prepaid, so the model must be rebuilt; see the deployment note.</a:t>
             </a:r>
           </a:p>
         </p:txBody>
@@ -654,7 +655,7 @@
           <a:lstStyle/>
           <a:p>
             <a:r>
-              <a:t>We are explicit about what the analysis cannot claim. The course forbids causal uplift claims from this data, and the literature shows high-risk customers can be the least responsive. That is the reason for the pilot.</a:t>
+              <a:t>An offer is a benefit (a discount) and a burden (a call). The new rule widens the senior gap compared with today's, partly because seniors pay more; the pilot reports seniors separately and Legal/DPO reviews each wave. Loyal low-risk customers rarely get offers, so watch for loyalty-penalty complaints.</a:t>
             </a:r>
           </a:p>
         </p:txBody>
@@ -724,7 +725,7 @@
           <a:lstStyle/>
           <a:p>
             <a:r>
-              <a:t>The wave is the recommended list scaled to the 7,043-customer base (22% of customers). Randomising inside the target list gives the causal effect we could not estimate from the data. Each offer is its own arm. Measured save rates replace assumptions in the configuration and the whole analysis re-runs.</a:t>
+              <a:t>Randomising inside the target list gives the causal effect the data cannot. The price of learning is the value forgone on the held-out half, about $10,363. Measured save rates replace the assumptions and the whole analysis re-runs.</a:t>
             </a:r>
           </a:p>
         </p:txBody>
@@ -794,7 +795,77 @@
           <a:lstStyle/>
           <a:p>
             <a:r>
-              <a:t>Close with the ask. If the true save rate is 20%, the rule says go after one wave 94% of the time; the significance test protects against acting on noise, the break-even test protects the budget. Then switch to the dashboard demo: change the save rate and budget, show the KPIs and the action list update, export the campaign file with its scenario ID.</a:t>
+              <a:t>Close with the ask. If the true save rate is 20%, the rule says go after one wave 95% of the time. The significance test protects against acting on noise; the break-even test protects the budget.</a:t>
+            </a:r>
+          </a:p>
+        </p:txBody>
+      </p:sp>
+      <p:sp>
+        <p:nvSpPr>
+          <p:cNvPr id="4" name="Slide Number Placeholder 3"/>
+          <p:cNvSpPr>
+            <a:spLocks noGrp="1"/>
+          </p:cNvSpPr>
+          <p:nvPr>
+            <p:ph type="sldNum" idx="5" sz="quarter"/>
+          </p:nvPr>
+        </p:nvSpPr>
+        <p:spPr/>
+      </p:sp>
+    </p:spTree>
+  </p:cSld>
+  <p:clrMapOvr>
+    <a:masterClrMapping/>
+  </p:clrMapOvr>
+</p:notes>
+</file>
+
+<file path=ppt/notesSlides/notesSlide14.xml><?xml version="1.0" encoding="utf-8"?>
+<p:notes xmlns:a="http://schemas.openxmlformats.org/drawingml/2006/main" xmlns:p="http://schemas.openxmlformats.org/presentationml/2006/main" xmlns:r="http://schemas.openxmlformats.org/officeDocument/2006/relationships">
+  <p:cSld>
+    <p:spTree>
+      <p:nvGrpSpPr>
+        <p:cNvPr id="1" name=""/>
+        <p:cNvGrpSpPr/>
+        <p:nvPr/>
+      </p:nvGrpSpPr>
+      <p:grpSpPr>
+        <a:xfrm>
+          <a:off x="0" y="0"/>
+          <a:ext cx="0" cy="0"/>
+          <a:chOff x="0" y="0"/>
+          <a:chExt cx="0" cy="0"/>
+        </a:xfrm>
+      </p:grpSpPr>
+      <p:sp>
+        <p:nvSpPr>
+          <p:cNvPr id="2" name="Slide Image Placeholder 1"/>
+          <p:cNvSpPr>
+            <a:spLocks noGrp="1"/>
+          </p:cNvSpPr>
+          <p:nvPr>
+            <p:ph type="sldImg" idx="2"/>
+          </p:nvPr>
+        </p:nvSpPr>
+        <p:spPr/>
+      </p:sp>
+      <p:sp>
+        <p:nvSpPr>
+          <p:cNvPr id="3" name="Notes Placeholder 2"/>
+          <p:cNvSpPr>
+            <a:spLocks noGrp="1"/>
+          </p:cNvSpPr>
+          <p:nvPr>
+            <p:ph type="body" idx="3" sz="quarter"/>
+          </p:nvPr>
+        </p:nvSpPr>
+        <p:spPr/>
+        <p:txBody>
+          <a:bodyPr/>
+          <a:lstStyle/>
+          <a:p>
+            <a:r>
+              <a:t>Follow the demo script: show the default view, change the budget, open the action list and explain one customer, export the campaign file, then lower the save rate on the assumptions page and show when not running the campaign is the right decision.</a:t>
             </a:r>
           </a:p>
         </p:txBody>
@@ -864,7 +935,7 @@
           <a:lstStyle/>
           <a:p>
             <a:r>
-              <a:t>The status quo is "highest churn risk first". Three things are missing: customer value, the cost of the offer, and whether the offer actually changes behaviour. Our KPIs are expected net value, ROI, customers contacted, precision among contacted, and coverage of high-risk, high-value customers.</a:t>
+              <a:t>If management remembers one slide, it is this one. The targeting gain holds in 100% of assumption draws; the save rate is the open question, which is why the ask is a pilot and not a roll-out.</a:t>
             </a:r>
           </a:p>
         </p:txBody>
@@ -934,7 +1005,7 @@
           <a:lstStyle/>
           <a:p>
             <a:r>
-              <a:t>Data readiness verdict: fit to design and demonstrate the method, not to size a real campaign. Cleaning was minor: eleven blank total charges for brand-new customers. Split 60/20/20; every choice made on validation, test touched once.</a:t>
+              <a:t>$468,468 is twelve months of expected margin lost to churn across 7,043 customers ($93,720 on the 1,409 test customers). The question is not who will leave but where an offer pays back. Our KPIs: expected net value, ROI, customers contacted, precision among contacted and coverage of high-risk, high-value customers.</a:t>
             </a:r>
           </a:p>
         </p:txBody>
@@ -1004,7 +1075,7 @@
           <a:lstStyle/>
           <a:p>
             <a:r>
-              <a:t>All three model families rank about equally well, so the simpler and well-calibrated model wins. Calibration matters because we multiply probabilities by money. SHAP on the gradient-boosting challenger agrees on the drivers: tenure, contract, fibre, missing tech support.</a:t>
+              <a:t>Calibration matters because we multiply probabilities by money. All three model families rank about equally, so the simpler and interpretable model wins; its odds ratios also become a points card for the call centre. Every choice was made on validation; the test customers were used once, for reporting.</a:t>
             </a:r>
           </a:p>
         </p:txBody>
@@ -1074,7 +1145,7 @@
           <a:lstStyle/>
           <a:p>
             <a:r>
-              <a:t>Value equals monthly charges times a 30% margin times about a year of discounted months, scaled by tenure. The dashed lines are the 75th percentiles, fixed on validation. The coloured points are who the recommended rule contacts.</a:t>
+              <a:t>Worked example: a customer paying 70 dollars a month is worth about $239 over a year of margin; at 60% risk the standard offer is worth $3.73 net. The save rate is the share of would-be leavers an offer keeps; we assume 20%, below the 30% common in the literature.</a:t>
             </a:r>
           </a:p>
         </p:txBody>
@@ -1144,7 +1215,7 @@
           <a:lstStyle/>
           <a:p>
             <a:r>
-              <a:t>Worked example: a customer paying 70 dollars a month is worth about $239; at 60% risk the standard offer is worth $3.73. Save rates are deliberately below the 30% literature convention because risky customers are not always responsive.</a:t>
+              <a:t>The whole campaign rides on one segment's response, so the pilot should report results for fibre and monthly-contract customers separately. Offers: $35 credit for moving to a 1-year contract for 150, 6 months free techsupport + onlinesecurity for 150, one-time $20 bill credit for 24.</a:t>
             </a:r>
           </a:p>
         </p:txBody>
@@ -1214,7 +1285,7 @@
           <a:lstStyle/>
           <a:p>
             <a:r>
-              <a:t>Same customers, same budget, same assumptions. Precision is the share of contacted customers who actually churned; HR/HV coverage is the share of high-risk, high-value customers reached. Risk-only has higher precision but lower value. Segment offers add $290 only under assumed save rates; with actual outcomes that extra gain is not distinguishable from zero, so the pilot must test offers.</a:t>
+              <a:t>Same customers, budget and assumptions. Precision is the share of contacted customers who actually left; risk-only is more precise but spends on customers who are not worth an offer. Valued with what these customers actually did, the gain is $1,077 (95% interval $229 to $2,002); the offer-matching part is not proven, so the pilot tests offers too.</a:t>
             </a:r>
           </a:p>
         </p:txBody>
@@ -1284,7 +1355,7 @@
           <a:lstStyle/>
           <a:p>
             <a:r>
-              <a:t>The x-axis is the budget as the share of customers the standard offer could reach; the recommended budget equals the standard offer for 24% of customers, about $42,238 for the whole base. Each extra step reaches customers with lower expected value. Beyond 27% of customers contacted nobody has positive expected value, so spending more destroys value.</a:t>
+              <a:t>The x-axis is the budget expressed as the share of customers the standard offer could reach. The recommended budget is about 2.6 times today's; it is only worth committing once the pilot confirms the save rate.</a:t>
             </a:r>
           </a:p>
         </p:txBody>
@@ -1354,7 +1425,7 @@
           <a:lstStyle/>
           <a:p>
             <a:r>
-              <a:t>The save rate and the value horizon dominate. A re-optimised plan never loses money because it drops customers whose value turns negative; a list frozen under pessimistic assumptions would lose $2,797. This is why we recommend measuring the save rate before scaling.</a:t>
+              <a:t>5,000 draws, every register assumption at once. Value horizon (months) and save rate of the standard offer drive most of the spread. If offers only reach churners who left for price or a competitor, a 20% save rate means keeping 43% of them: ambitious. Below 8.5% nobody is worth contacting.</a:t>
             </a:r>
           </a:p>
         </p:txBody>
@@ -4432,7 +4503,7 @@
                 </a:solidFill>
                 <a:latin typeface="Segoe UI"/>
               </a:rPr>
-              <a:t>Who should get a retention offer?</a:t>
+              <a:t>Spend the retention budget where it returns the most</a:t>
             </a:r>
           </a:p>
         </p:txBody>
@@ -4505,7 +4576,7 @@
                 </a:solidFill>
                 <a:latin typeface="Segoe UI"/>
               </a:rPr>
-              <a:t>• Decision: which customers receive an offer, with which offer, and how much budget to commit</a:t>
+              <a:t>• Decision: which customers get a retention offer, which offer, and how much to spend</a:t>
             </a:r>
           </a:p>
           <a:p>
@@ -4521,7 +4592,7 @@
                 </a:solidFill>
                 <a:latin typeface="Segoe UI"/>
               </a:rPr>
-              <a:t>• Data: IBM Telco Customer Churn sample (7,043 customers)</a:t>
+              <a:t>• Answer: rank by expected value, not by churn risk alone, and prove the save rate in a pilot</a:t>
             </a:r>
           </a:p>
           <a:p>
@@ -4537,7 +4608,7 @@
                 </a:solidFill>
                 <a:latin typeface="Segoe UI"/>
               </a:rPr>
-              <a:t>• Recommendation: expected-value targeting, tested in a randomised pilot</a:t>
+              <a:t>• Ask: approve one randomised pilot wave of 1,620 customers</a:t>
             </a:r>
           </a:p>
         </p:txBody>
@@ -4571,7 +4642,7 @@
                 </a:solidFill>
                 <a:latin typeface="Segoe UI"/>
               </a:rPr>
-              <a:t>Retention Lab | Profit-aware churn &amp; retention targeting | 1/13</a:t>
+              <a:t>Retention Lab | Profit-aware churn &amp; retention targeting | 1/14</a:t>
             </a:r>
           </a:p>
         </p:txBody>
@@ -4666,7 +4737,7 @@
                 </a:solidFill>
                 <a:latin typeface="Segoe UI"/>
               </a:rPr>
-              <a:t>Fairness and customer experience</a:t>
+              <a:t>Outside the sample the margins get thinner</a:t>
             </a:r>
           </a:p>
         </p:txBody>
@@ -4705,7 +4776,7 @@
                 </a:solidFill>
                 <a:latin typeface="Segoe UI"/>
               </a:rPr>
-              <a:t>• Seniors contacted 3.7x as often - mostly higher risk, partly higher value</a:t>
+              <a:t>• Real churn is far below the sample's 27%</a:t>
             </a:r>
           </a:p>
           <a:p>
@@ -4721,7 +4792,7 @@
                 </a:solidFill>
                 <a:latin typeface="Segoe UI"/>
               </a:rPr>
-              <a:t>• No protected attribute is a model input; every wave is audited</a:t>
+              <a:t>• At 15% churn only 7% of customers are worth this offer</a:t>
             </a:r>
           </a:p>
           <a:p>
@@ -4737,14 +4808,30 @@
                 </a:solidFill>
                 <a:latin typeface="Segoe UI"/>
               </a:rPr>
-              <a:t>• Loyal low-risk customers rarely get offers: add a loyalty benefit</a:t>
+              <a:t>• Vietnamese prices: small bills but SMS contact keeps 18% worth an offer</a:t>
+            </a:r>
+          </a:p>
+          <a:p>
+            <a:pPr>
+              <a:spcAft>
+                <a:spcPts val="800"/>
+              </a:spcAft>
+            </a:pPr>
+            <a:r>
+              <a:rPr sz="1500" b="0">
+                <a:solidFill>
+                  <a:srgbClr val="0B0B0B"/>
+                </a:solidFill>
+                <a:latin typeface="Segoe UI"/>
+              </a:rPr>
+              <a:t>• Lower churn needs larger pilots; rebuild the model on our own data</a:t>
             </a:r>
           </a:p>
         </p:txBody>
       </p:sp>
       <p:pic>
         <p:nvPicPr>
-          <p:cNvPr id="5" name="Picture 4" descr="fairness.png"/>
+          <p:cNvPr id="5" name="Picture 4" descr="stress_test.png"/>
           <p:cNvPicPr>
             <a:picLocks noChangeAspect="1"/>
           </p:cNvPicPr>
@@ -4759,7 +4846,7 @@
         <p:spPr>
           <a:xfrm>
             <a:off x="5303520" y="1143000"/>
-            <a:ext cx="6583680" cy="2779776"/>
+            <a:ext cx="6583680" cy="2753175"/>
           </a:xfrm>
           <a:prstGeom prst="rect">
             <a:avLst/>
@@ -4795,7 +4882,7 @@
                 </a:solidFill>
                 <a:latin typeface="Segoe UI"/>
               </a:rPr>
-              <a:t>Retention Lab | Profit-aware churn &amp; retention targeting | 10/13</a:t>
+              <a:t>Retention Lab | Profit-aware churn &amp; retention targeting | 10/14</a:t>
             </a:r>
           </a:p>
         </p:txBody>
@@ -4890,7 +4977,7 @@
                 </a:solidFill>
                 <a:latin typeface="Segoe UI"/>
               </a:rPr>
-              <a:t>Risks and limits</a:t>
+              <a:t>Fairness, experience and compliance are managed</a:t>
             </a:r>
           </a:p>
         </p:txBody>
@@ -4904,7 +4991,7 @@
         <p:spPr>
           <a:xfrm>
             <a:off x="502920" y="1143000"/>
-            <a:ext cx="11155680" cy="4754880"/>
+            <a:ext cx="4572000" cy="4754880"/>
           </a:xfrm>
           <a:prstGeom prst="rect">
             <a:avLst/>
@@ -4923,13 +5010,13 @@
               </a:spcAft>
             </a:pPr>
             <a:r>
-              <a:rPr sz="1800" b="0">
+              <a:rPr sz="1500" b="0">
                 <a:solidFill>
                   <a:srgbClr val="0B0B0B"/>
                 </a:solidFill>
                 <a:latin typeface="Segoe UI"/>
               </a:rPr>
-              <a:t>• No causal evidence: save rates are assumptions; contact can even raise churn</a:t>
+              <a:t>• Seniors contacted 3.3x as often as others (2.6x under today's rule)</a:t>
             </a:r>
           </a:p>
           <a:p>
@@ -4939,13 +5026,13 @@
               </a:spcAft>
             </a:pPr>
             <a:r>
-              <a:rPr sz="1800" b="0">
+              <a:rPr sz="1500" b="0">
                 <a:solidFill>
                   <a:srgbClr val="0B0B0B"/>
                 </a:solidFill>
                 <a:latin typeface="Segoe UI"/>
               </a:rPr>
-              <a:t>• Teaching sample: fictional US data, 26.5% churn vs about 1% a month in reality</a:t>
+              <a:t>• 1.7x after adjusting for risk: reviewed with Legal/DPO before each wave</a:t>
             </a:r>
           </a:p>
           <a:p>
@@ -4955,13 +5042,13 @@
               </a:spcAft>
             </a:pPr>
             <a:r>
-              <a:rPr sz="1800" b="0">
+              <a:rPr sz="1500" b="0">
                 <a:solidFill>
                   <a:srgbClr val="0B0B0B"/>
                 </a:solidFill>
                 <a:latin typeface="Segoe UI"/>
               </a:rPr>
-              <a:t>• Vietnam: about 90% prepaid; rebuild the model on our own data</a:t>
+              <a:t>• Age and gender are not model inputs; every wave is audited</a:t>
             </a:r>
           </a:p>
           <a:p>
@@ -4971,20 +5058,44 @@
               </a:spcAft>
             </a:pPr>
             <a:r>
-              <a:rPr sz="1800" b="0">
+              <a:rPr sz="1500" b="0">
                 <a:solidFill>
                   <a:srgbClr val="0B0B0B"/>
                 </a:solidFill>
                 <a:latin typeface="Segoe UI"/>
               </a:rPr>
-              <a:t>• Compliance: consent, Do-Not-Call, calls 08:00-17:00, one call per 24 hours, DPIA</a:t>
-            </a:r>
-          </a:p>
-        </p:txBody>
-      </p:sp>
-      <p:sp>
-        <p:nvSpPr>
-          <p:cNvPr id="5" name="TextBox 4"/>
+              <a:t>• Consent, Do-Not-Call checks, contact limits and a data-protection impact assessment</a:t>
+            </a:r>
+          </a:p>
+        </p:txBody>
+      </p:sp>
+      <p:pic>
+        <p:nvPicPr>
+          <p:cNvPr id="5" name="Picture 4" descr="fairness.png"/>
+          <p:cNvPicPr>
+            <a:picLocks noChangeAspect="1"/>
+          </p:cNvPicPr>
+          <p:nvPr/>
+        </p:nvPicPr>
+        <p:blipFill>
+          <a:blip r:embed="rId2"/>
+          <a:stretch>
+            <a:fillRect/>
+          </a:stretch>
+        </p:blipFill>
+        <p:spPr>
+          <a:xfrm>
+            <a:off x="5303520" y="1143000"/>
+            <a:ext cx="6583680" cy="2779776"/>
+          </a:xfrm>
+          <a:prstGeom prst="rect">
+            <a:avLst/>
+          </a:prstGeom>
+        </p:spPr>
+      </p:pic>
+      <p:sp>
+        <p:nvSpPr>
+          <p:cNvPr id="6" name="TextBox 5"/>
           <p:cNvSpPr txBox="1"/>
           <p:nvPr/>
         </p:nvSpPr>
@@ -5011,7 +5122,7 @@
                 </a:solidFill>
                 <a:latin typeface="Segoe UI"/>
               </a:rPr>
-              <a:t>Retention Lab | Profit-aware churn &amp; retention targeting | 11/13</a:t>
+              <a:t>Retention Lab | Profit-aware churn &amp; retention targeting | 11/14</a:t>
             </a:r>
           </a:p>
         </p:txBody>
@@ -5145,7 +5256,7 @@
                 </a:solidFill>
                 <a:latin typeface="Segoe UI"/>
               </a:rPr>
-              <a:t>• One wave: 1,550 customers, 775 offered, 775 held out at random</a:t>
+              <a:t>• 1,620 customers: 810 offered, 810 held out at random</a:t>
             </a:r>
           </a:p>
           <a:p>
@@ -5161,7 +5272,7 @@
                 </a:solidFill>
                 <a:latin typeface="Segoe UI"/>
               </a:rPr>
-              <a:t>• Outcome: churn after 90 days; save rate = 1 - churn(offered) / churn(holdout)</a:t>
+              <a:t>• Save rate = 1 - churn of offered / churn of held out, after 90 days</a:t>
             </a:r>
           </a:p>
           <a:p>
@@ -5177,7 +5288,7 @@
                 </a:solidFill>
                 <a:latin typeface="Segoe UI"/>
               </a:rPr>
-              <a:t>• Detects a save rate of about 12% or more in one wave; break-even is 13.9%</a:t>
+              <a:t>• One wave detects a save rate of about 12%; break-even is 13.8%</a:t>
             </a:r>
           </a:p>
           <a:p>
@@ -5193,7 +5304,23 @@
                 </a:solidFill>
                 <a:latin typeface="Segoe UI"/>
               </a:rPr>
-              <a:t>• Offer and contact cost about $21,125</a:t>
+              <a:t>• Cost about $22,875; expected net value of the offered half $10,363</a:t>
+            </a:r>
+          </a:p>
+          <a:p>
+            <a:pPr>
+              <a:spcAft>
+                <a:spcPts val="800"/>
+              </a:spcAft>
+            </a:pPr>
+            <a:r>
+              <a:rPr sz="1800" b="0">
+                <a:solidFill>
+                  <a:srgbClr val="0B0B0B"/>
+                </a:solidFill>
+                <a:latin typeface="Segoe UI"/>
+              </a:rPr>
+              <a:t>• Decision about 19 weeks after approval: set-up, outcome window, read-out</a:t>
             </a:r>
           </a:p>
         </p:txBody>
@@ -5227,7 +5354,7 @@
                 </a:solidFill>
                 <a:latin typeface="Segoe UI"/>
               </a:rPr>
-              <a:t>Retention Lab | Profit-aware churn &amp; retention targeting | 12/13</a:t>
+              <a:t>Retention Lab | Profit-aware churn &amp; retention targeting | 12/14</a:t>
             </a:r>
           </a:p>
         </p:txBody>
@@ -5361,7 +5488,7 @@
                 </a:solidFill>
                 <a:latin typeface="Segoe UI"/>
               </a:rPr>
-              <a:t>• Approve one pilot wave: 1,550 customers, half held out, about $21,125</a:t>
+              <a:t>• Approve one pilot wave: 1,620 customers, half held out, about $22,875</a:t>
             </a:r>
           </a:p>
           <a:p>
@@ -5393,7 +5520,7 @@
                 </a:solidFill>
                 <a:latin typeface="Segoe UI"/>
               </a:rPr>
-              <a:t>• Agree the rule now: go if the effect is significant and at least 13.9%; else stop or extend</a:t>
+              <a:t>• Agree the rule now: go if significant and at least 13.8%; stop if clearly below</a:t>
             </a:r>
           </a:p>
           <a:p>
@@ -5409,7 +5536,7 @@
                 </a:solidFill>
                 <a:latin typeface="Segoe UI"/>
               </a:rPr>
-              <a:t>• Live demo: dashboard - KPIs, action list, scenarios</a:t>
+              <a:t>• Otherwise extend, at most 2 more waves</a:t>
             </a:r>
           </a:p>
         </p:txBody>
@@ -5443,7 +5570,207 @@
                 </a:solidFill>
                 <a:latin typeface="Segoe UI"/>
               </a:rPr>
-              <a:t>Retention Lab | Profit-aware churn &amp; retention targeting | 13/13</a:t>
+              <a:t>Retention Lab | Profit-aware churn &amp; retention targeting | 13/14</a:t>
+            </a:r>
+          </a:p>
+        </p:txBody>
+      </p:sp>
+    </p:spTree>
+  </p:cSld>
+  <p:clrMapOvr>
+    <a:masterClrMapping/>
+  </p:clrMapOvr>
+</p:sld>
+</file>
+
+<file path=ppt/slides/slide14.xml><?xml version="1.0" encoding="utf-8"?>
+<p:sld xmlns:a="http://schemas.openxmlformats.org/drawingml/2006/main" xmlns:p="http://schemas.openxmlformats.org/presentationml/2006/main" xmlns:r="http://schemas.openxmlformats.org/officeDocument/2006/relationships">
+  <p:cSld>
+    <p:spTree>
+      <p:nvGrpSpPr>
+        <p:cNvPr id="1" name=""/>
+        <p:cNvGrpSpPr/>
+        <p:nvPr/>
+      </p:nvGrpSpPr>
+      <p:grpSpPr/>
+      <p:sp>
+        <p:nvSpPr>
+          <p:cNvPr id="2" name="Rectangle 1"/>
+          <p:cNvSpPr/>
+          <p:nvPr/>
+        </p:nvSpPr>
+        <p:spPr>
+          <a:xfrm>
+            <a:off x="0" y="0"/>
+            <a:ext cx="164592" cy="6858000"/>
+          </a:xfrm>
+          <a:prstGeom prst="rect">
+            <a:avLst/>
+          </a:prstGeom>
+          <a:solidFill>
+            <a:srgbClr val="2A78D6"/>
+          </a:solidFill>
+          <a:ln>
+            <a:noFill/>
+          </a:ln>
+        </p:spPr>
+        <p:style>
+          <a:lnRef idx="1">
+            <a:schemeClr val="accent1"/>
+          </a:lnRef>
+          <a:fillRef idx="3">
+            <a:schemeClr val="accent1"/>
+          </a:fillRef>
+          <a:effectRef idx="2">
+            <a:schemeClr val="accent1"/>
+          </a:effectRef>
+          <a:fontRef idx="minor">
+            <a:schemeClr val="lt1"/>
+          </a:fontRef>
+        </p:style>
+        <p:txBody>
+          <a:bodyPr rtlCol="0" anchor="ctr"/>
+          <a:lstStyle/>
+          <a:p>
+            <a:pPr algn="ctr"/>
+          </a:p>
+        </p:txBody>
+      </p:sp>
+      <p:sp>
+        <p:nvSpPr>
+          <p:cNvPr id="3" name="TextBox 2"/>
+          <p:cNvSpPr txBox="1"/>
+          <p:nvPr/>
+        </p:nvSpPr>
+        <p:spPr>
+          <a:xfrm>
+            <a:off x="502920" y="320040"/>
+            <a:ext cx="11155680" cy="822960"/>
+          </a:xfrm>
+          <a:prstGeom prst="rect">
+            <a:avLst/>
+          </a:prstGeom>
+          <a:noFill/>
+        </p:spPr>
+        <p:txBody>
+          <a:bodyPr wrap="square">
+            <a:spAutoFit/>
+          </a:bodyPr>
+          <a:lstStyle/>
+          <a:p>
+            <a:r>
+              <a:rPr sz="2800" b="1">
+                <a:solidFill>
+                  <a:srgbClr val="0B0B0B"/>
+                </a:solidFill>
+                <a:latin typeface="Segoe UI"/>
+              </a:rPr>
+              <a:t>Live demo: the dashboard</a:t>
+            </a:r>
+          </a:p>
+        </p:txBody>
+      </p:sp>
+      <p:sp>
+        <p:nvSpPr>
+          <p:cNvPr id="4" name="TextBox 3"/>
+          <p:cNvSpPr txBox="1"/>
+          <p:nvPr/>
+        </p:nvSpPr>
+        <p:spPr>
+          <a:xfrm>
+            <a:off x="502920" y="1143000"/>
+            <a:ext cx="11155680" cy="4754880"/>
+          </a:xfrm>
+          <a:prstGeom prst="rect">
+            <a:avLst/>
+          </a:prstGeom>
+          <a:noFill/>
+        </p:spPr>
+        <p:txBody>
+          <a:bodyPr wrap="square">
+            <a:spAutoFit/>
+          </a:bodyPr>
+          <a:lstStyle/>
+          <a:p>
+            <a:pPr>
+              <a:spcAft>
+                <a:spcPts val="800"/>
+              </a:spcAft>
+            </a:pPr>
+            <a:r>
+              <a:rPr sz="1800" b="0">
+                <a:solidFill>
+                  <a:srgbClr val="0B0B0B"/>
+                </a:solidFill>
+                <a:latin typeface="Segoe UI"/>
+              </a:rPr>
+              <a:t>• Decision page: KPIs, who gets an offer, action list and export</a:t>
+            </a:r>
+          </a:p>
+          <a:p>
+            <a:pPr>
+              <a:spcAft>
+                <a:spcPts val="800"/>
+              </a:spcAft>
+            </a:pPr>
+            <a:r>
+              <a:rPr sz="1800" b="0">
+                <a:solidFill>
+                  <a:srgbClr val="0B0B0B"/>
+                </a:solidFill>
+                <a:latin typeface="Segoe UI"/>
+              </a:rPr>
+              <a:t>• Assumptions page: change the save rate and watch the chance of a loss move</a:t>
+            </a:r>
+          </a:p>
+          <a:p>
+            <a:pPr>
+              <a:spcAft>
+                <a:spcPts val="800"/>
+              </a:spcAft>
+            </a:pPr>
+            <a:r>
+              <a:rPr sz="1800" b="0">
+                <a:solidFill>
+                  <a:srgbClr val="0B0B0B"/>
+                </a:solidFill>
+                <a:latin typeface="Segoe UI"/>
+              </a:rPr>
+              <a:t>• Model evidence: odds ratios and the points scorecard</a:t>
+            </a:r>
+          </a:p>
+        </p:txBody>
+      </p:sp>
+      <p:sp>
+        <p:nvSpPr>
+          <p:cNvPr id="5" name="TextBox 4"/>
+          <p:cNvSpPr txBox="1"/>
+          <p:nvPr/>
+        </p:nvSpPr>
+        <p:spPr>
+          <a:xfrm>
+            <a:off x="502920" y="6446520"/>
+            <a:ext cx="11155680" cy="320040"/>
+          </a:xfrm>
+          <a:prstGeom prst="rect">
+            <a:avLst/>
+          </a:prstGeom>
+          <a:noFill/>
+        </p:spPr>
+        <p:txBody>
+          <a:bodyPr wrap="none">
+            <a:spAutoFit/>
+          </a:bodyPr>
+          <a:lstStyle/>
+          <a:p>
+            <a:r>
+              <a:rPr sz="1000" b="0">
+                <a:solidFill>
+                  <a:srgbClr val="898781"/>
+                </a:solidFill>
+                <a:latin typeface="Segoe UI"/>
+              </a:rPr>
+              <a:t>Retention Lab | Profit-aware churn &amp; retention targeting | 14/14</a:t>
             </a:r>
           </a:p>
         </p:txBody>
@@ -5538,7 +5865,7 @@
                 </a:solidFill>
                 <a:latin typeface="Segoe UI"/>
               </a:rPr>
-              <a:t>Today's rule wastes part of the budget</a:t>
+              <a:t>Target by expected value, then prove the save rate</a:t>
             </a:r>
           </a:p>
         </p:txBody>
@@ -5572,7 +5899,7 @@
                 </a:solidFill>
                 <a:latin typeface="Segoe UI"/>
               </a:rPr>
-              <a:t>Calling the riskiest customers ignores what they are worth and what the offer costs</a:t>
+              <a:t>Executive summary</a:t>
             </a:r>
           </a:p>
         </p:txBody>
@@ -5611,7 +5938,7 @@
                 </a:solidFill>
                 <a:latin typeface="Segoe UI"/>
               </a:rPr>
-              <a:t>• Budget covers an offer for only 10% of customers ($3,500 per 1,409)</a:t>
+              <a:t>• Same $3,500 budget: +$1,368 expected versus calling the riskiest customers</a:t>
             </a:r>
           </a:p>
           <a:p>
@@ -5627,7 +5954,7 @@
                 </a:solidFill>
                 <a:latin typeface="Segoe UI"/>
               </a:rPr>
-              <a:t>• Every offer costs money even if the customer would have stayed</a:t>
+              <a:t>• Who: fibre customers on monthly contracts with high bills; not low-risk or low-bill customers</a:t>
             </a:r>
           </a:p>
           <a:p>
@@ -5643,7 +5970,7 @@
                 </a:solidFill>
                 <a:latin typeface="Segoe UI"/>
               </a:rPr>
-              <a:t>• A very risky customer with a small bill may not repay the offer</a:t>
+              <a:t>• Budget: about $45,737 for the base; stop where the next step returns under 10%</a:t>
             </a:r>
           </a:p>
           <a:p>
@@ -5659,7 +5986,23 @@
                 </a:solidFill>
                 <a:latin typeface="Segoe UI"/>
               </a:rPr>
-              <a:t>• Decision owner: Head of Retention; Finance approves budget; Legal/DPO approves contact</a:t>
+              <a:t>• Who to target is robust; how much an offer saves (20% assumed) is not</a:t>
+            </a:r>
+          </a:p>
+          <a:p>
+            <a:pPr>
+              <a:spcAft>
+                <a:spcPts val="800"/>
+              </a:spcAft>
+            </a:pPr>
+            <a:r>
+              <a:rPr sz="1800" b="0">
+                <a:solidFill>
+                  <a:srgbClr val="0B0B0B"/>
+                </a:solidFill>
+                <a:latin typeface="Segoe UI"/>
+              </a:rPr>
+              <a:t>• Ask: one pilot wave, half held out, about $22,875 of offers and contacts</a:t>
             </a:r>
           </a:p>
         </p:txBody>
@@ -5693,7 +6036,7 @@
                 </a:solidFill>
                 <a:latin typeface="Segoe UI"/>
               </a:rPr>
-              <a:t>Retention Lab | Profit-aware churn &amp; retention targeting | 2/13</a:t>
+              <a:t>Retention Lab | Profit-aware churn &amp; retention targeting | 2/14</a:t>
             </a:r>
           </a:p>
         </p:txBody>
@@ -5788,7 +6131,7 @@
                 </a:solidFill>
                 <a:latin typeface="Segoe UI"/>
               </a:rPr>
-              <a:t>The data: clean, but a teaching sample</a:t>
+              <a:t>Churn puts $468,468 of margin at risk</a:t>
             </a:r>
           </a:p>
         </p:txBody>
@@ -5801,7 +6144,41 @@
         </p:nvSpPr>
         <p:spPr>
           <a:xfrm>
-            <a:off x="502920" y="1143000"/>
+            <a:off x="502920" y="1051560"/>
+            <a:ext cx="11155680" cy="548640"/>
+          </a:xfrm>
+          <a:prstGeom prst="rect">
+            <a:avLst/>
+          </a:prstGeom>
+          <a:noFill/>
+        </p:spPr>
+        <p:txBody>
+          <a:bodyPr wrap="square">
+            <a:spAutoFit/>
+          </a:bodyPr>
+          <a:lstStyle/>
+          <a:p>
+            <a:r>
+              <a:rPr sz="1600" b="0">
+                <a:solidFill>
+                  <a:srgbClr val="52514E"/>
+                </a:solidFill>
+                <a:latin typeface="Segoe UI"/>
+              </a:rPr>
+              <a:t>Today's rule calls the riskiest customers, whatever they are worth</a:t>
+            </a:r>
+          </a:p>
+        </p:txBody>
+      </p:sp>
+      <p:sp>
+        <p:nvSpPr>
+          <p:cNvPr id="5" name="TextBox 4"/>
+          <p:cNvSpPr txBox="1"/>
+          <p:nvPr/>
+        </p:nvSpPr>
+        <p:spPr>
+          <a:xfrm>
+            <a:off x="502920" y="1645920"/>
             <a:ext cx="4572000" cy="4754880"/>
           </a:xfrm>
           <a:prstGeom prst="rect">
@@ -5827,7 +6204,7 @@
                 </a:solidFill>
                 <a:latin typeface="Segoe UI"/>
               </a:rPr>
-              <a:t>• 26.5% churn; month-to-month, new, fibre and e-cheque customers churn most</a:t>
+              <a:t>• 26.5% of customers churn; monthly-contract, new, fibre and e-cheque customers most</a:t>
             </a:r>
           </a:p>
           <a:p>
@@ -5843,7 +6220,7 @@
                 </a:solidFill>
                 <a:latin typeface="Segoe UI"/>
               </a:rPr>
-              <a:t>• No offer or campaign data: save rates must be assumed</a:t>
+              <a:t>• The budget covers an offer for 10% of customers</a:t>
             </a:r>
           </a:p>
           <a:p>
@@ -5859,14 +6236,30 @@
                 </a:solidFill>
                 <a:latin typeface="Segoe UI"/>
               </a:rPr>
-              <a:t>• Fictional US company; real US postpaid churn is about 1% a month</a:t>
+              <a:t>• Every offer costs money, even when the customer would have stayed</a:t>
+            </a:r>
+          </a:p>
+          <a:p>
+            <a:pPr>
+              <a:spcAft>
+                <a:spcPts val="800"/>
+              </a:spcAft>
+            </a:pPr>
+            <a:r>
+              <a:rPr sz="1500" b="0">
+                <a:solidFill>
+                  <a:srgbClr val="0B0B0B"/>
+                </a:solidFill>
+                <a:latin typeface="Segoe UI"/>
+              </a:rPr>
+              <a:t>• Owner: Head of Retention; Finance approves budget; Legal/DPO approves contact</a:t>
             </a:r>
           </a:p>
         </p:txBody>
       </p:sp>
       <p:pic>
         <p:nvPicPr>
-          <p:cNvPr id="5" name="Picture 4" descr="eda_drivers.png"/>
+          <p:cNvPr id="6" name="Picture 5" descr="eda_drivers.png"/>
           <p:cNvPicPr>
             <a:picLocks noChangeAspect="1"/>
           </p:cNvPicPr>
@@ -5880,7 +6273,7 @@
         </p:blipFill>
         <p:spPr>
           <a:xfrm>
-            <a:off x="5303520" y="1143000"/>
+            <a:off x="5303520" y="1645920"/>
             <a:ext cx="6583680" cy="3890356"/>
           </a:xfrm>
           <a:prstGeom prst="rect">
@@ -5890,7 +6283,7 @@
       </p:pic>
       <p:sp>
         <p:nvSpPr>
-          <p:cNvPr id="6" name="TextBox 5"/>
+          <p:cNvPr id="7" name="TextBox 6"/>
           <p:cNvSpPr txBox="1"/>
           <p:nvPr/>
         </p:nvSpPr>
@@ -5917,7 +6310,7 @@
                 </a:solidFill>
                 <a:latin typeface="Segoe UI"/>
               </a:rPr>
-              <a:t>Retention Lab | Profit-aware churn &amp; retention targeting | 3/13</a:t>
+              <a:t>Retention Lab | Profit-aware churn &amp; retention targeting | 3/14</a:t>
             </a:r>
           </a:p>
         </p:txBody>
@@ -6012,7 +6405,7 @@
                 </a:solidFill>
                 <a:latin typeface="Segoe UI"/>
               </a:rPr>
-              <a:t>A calibrated model ranks churners well</a:t>
+              <a:t>The model ranks churners well and is checked in money</a:t>
             </a:r>
           </a:p>
         </p:txBody>
@@ -6051,7 +6444,7 @@
                 </a:solidFill>
                 <a:latin typeface="Segoe UI"/>
               </a:rPr>
-              <a:t>• Logistic regression chosen over random forest and XGBoost by a pre-set rule</a:t>
+              <a:t>• Logistic regression, chosen over random forest and XGBoost by a rule fixed in advance</a:t>
             </a:r>
           </a:p>
           <a:p>
@@ -6067,7 +6460,7 @@
                 </a:solidFill>
                 <a:latin typeface="Segoe UI"/>
               </a:rPr>
-              <a:t>• PR-AUC 0.62 vs 0.27 random; ROC-AUC 0.83</a:t>
+              <a:t>• Finds churners: ROC-AUC 0.83; PR-AUC 0.62 vs 0.27 by chance</a:t>
             </a:r>
           </a:p>
           <a:p>
@@ -6083,7 +6476,7 @@
                 </a:solidFill>
                 <a:latin typeface="Segoe UI"/>
               </a:rPr>
-              <a:t>• Probabilities off by 2.0% on average (ECE)</a:t>
+              <a:t>• Probabilities within 1.9 points of observed churn</a:t>
             </a:r>
           </a:p>
           <a:p>
@@ -6099,7 +6492,23 @@
                 </a:solidFill>
                 <a:latin typeface="Segoe UI"/>
               </a:rPr>
-              <a:t>• Predicts who leaves, not who an offer keeps</a:t>
+              <a:t>• In money the three models are within $194 on validation</a:t>
+            </a:r>
+          </a:p>
+          <a:p>
+            <a:pPr>
+              <a:spcAft>
+                <a:spcPts val="800"/>
+              </a:spcAft>
+            </a:pPr>
+            <a:r>
+              <a:rPr sz="1500" b="0">
+                <a:solidFill>
+                  <a:srgbClr val="0B0B0B"/>
+                </a:solidFill>
+                <a:latin typeface="Segoe UI"/>
+              </a:rPr>
+              <a:t>• It predicts who leaves, not who an offer would keep</a:t>
             </a:r>
           </a:p>
         </p:txBody>
@@ -6157,7 +6566,7 @@
                 </a:solidFill>
                 <a:latin typeface="Segoe UI"/>
               </a:rPr>
-              <a:t>Retention Lab | Profit-aware churn &amp; retention targeting | 4/13</a:t>
+              <a:t>Retention Lab | Profit-aware churn &amp; retention targeting | 4/14</a:t>
             </a:r>
           </a:p>
         </p:txBody>
@@ -6252,7 +6661,7 @@
                 </a:solidFill>
                 <a:latin typeface="Segoe UI"/>
               </a:rPr>
-              <a:t>Risk and value only partly overlap</a:t>
+              <a:t>Offer only where expected value beats the cost</a:t>
             </a:r>
           </a:p>
         </p:txBody>
@@ -6265,8 +6674,42 @@
         </p:nvSpPr>
         <p:spPr>
           <a:xfrm>
-            <a:off x="502920" y="1143000"/>
-            <a:ext cx="4572000" cy="4754880"/>
+            <a:off x="502920" y="1051560"/>
+            <a:ext cx="11155680" cy="548640"/>
+          </a:xfrm>
+          <a:prstGeom prst="rect">
+            <a:avLst/>
+          </a:prstGeom>
+          <a:noFill/>
+        </p:spPr>
+        <p:txBody>
+          <a:bodyPr wrap="square">
+            <a:spAutoFit/>
+          </a:bodyPr>
+          <a:lstStyle/>
+          <a:p>
+            <a:r>
+              <a:rPr sz="1600" b="0">
+                <a:solidFill>
+                  <a:srgbClr val="52514E"/>
+                </a:solidFill>
+                <a:latin typeface="Segoe UI"/>
+              </a:rPr>
+              <a:t>Expected value = churn probability x save rate x customer value - (offer + contact cost)</a:t>
+            </a:r>
+          </a:p>
+        </p:txBody>
+      </p:sp>
+      <p:sp>
+        <p:nvSpPr>
+          <p:cNvPr id="5" name="TextBox 4"/>
+          <p:cNvSpPr txBox="1"/>
+          <p:nvPr/>
+        </p:nvSpPr>
+        <p:spPr>
+          <a:xfrm>
+            <a:off x="502920" y="1645920"/>
+            <a:ext cx="11155680" cy="4754880"/>
           </a:xfrm>
           <a:prstGeom prst="rect">
             <a:avLst/>
@@ -6285,13 +6728,13 @@
               </a:spcAft>
             </a:pPr>
             <a:r>
-              <a:rPr sz="1500" b="0">
+              <a:rPr sz="1800" b="0">
                 <a:solidFill>
                   <a:srgbClr val="0B0B0B"/>
                 </a:solidFill>
                 <a:latin typeface="Segoe UI"/>
               </a:rPr>
-              <a:t>• Risk-only spends almost the whole budget on high-risk, low-value customers</a:t>
+              <a:t>• Contact only customers with positive expected value</a:t>
             </a:r>
           </a:p>
           <a:p>
@@ -6301,13 +6744,13 @@
               </a:spcAft>
             </a:pPr>
             <a:r>
-              <a:rPr sz="1500" b="0">
+              <a:rPr sz="1800" b="0">
                 <a:solidFill>
                   <a:srgbClr val="0B0B0B"/>
                 </a:solidFill>
                 <a:latin typeface="Segoe UI"/>
               </a:rPr>
-              <a:t>• The recommended rule reaches all 51 high-risk, high-value customers</a:t>
+              <a:t>• An optimiser picks customers and one offer each within budget, at most 30% contacted</a:t>
             </a:r>
           </a:p>
           <a:p>
@@ -6317,41 +6760,33 @@
               </a:spcAft>
             </a:pPr>
             <a:r>
-              <a:rPr sz="1500" b="0">
+              <a:rPr sz="1800" b="0">
                 <a:solidFill>
                   <a:srgbClr val="0B0B0B"/>
                 </a:solidFill>
                 <a:latin typeface="Segoe UI"/>
               </a:rPr>
-              <a:t>• It adds valuable customers at moderate risk</a:t>
-            </a:r>
-          </a:p>
-        </p:txBody>
-      </p:sp>
-      <p:pic>
-        <p:nvPicPr>
-          <p:cNvPr id="5" name="Picture 4" descr="risk_value.png"/>
-          <p:cNvPicPr>
-            <a:picLocks noChangeAspect="1"/>
-          </p:cNvPicPr>
-          <p:nvPr/>
-        </p:nvPicPr>
-        <p:blipFill>
-          <a:blip r:embed="rId2"/>
-          <a:stretch>
-            <a:fillRect/>
-          </a:stretch>
-        </p:blipFill>
-        <p:spPr>
-          <a:xfrm>
-            <a:off x="5303520" y="1143000"/>
-            <a:ext cx="6583680" cy="4535424"/>
-          </a:xfrm>
-          <a:prstGeom prst="rect">
-            <a:avLst/>
-          </a:prstGeom>
-        </p:spPr>
-      </p:pic>
+              <a:t>• Four offers with eligibility rules: bill credit, contract upgrade, service bundle, loyalty reward</a:t>
+            </a:r>
+          </a:p>
+          <a:p>
+            <a:pPr>
+              <a:spcAft>
+                <a:spcPts val="800"/>
+              </a:spcAft>
+            </a:pPr>
+            <a:r>
+              <a:rPr sz="1800" b="0">
+                <a:solidFill>
+                  <a:srgbClr val="0B0B0B"/>
+                </a:solidFill>
+                <a:latin typeface="Segoe UI"/>
+              </a:rPr>
+              <a:t>• Every cost and save rate is a visible, sourced assumption</a:t>
+            </a:r>
+          </a:p>
+        </p:txBody>
+      </p:sp>
       <p:sp>
         <p:nvSpPr>
           <p:cNvPr id="6" name="TextBox 5"/>
@@ -6381,7 +6816,7 @@
                 </a:solidFill>
                 <a:latin typeface="Segoe UI"/>
               </a:rPr>
-              <a:t>Retention Lab | Profit-aware churn &amp; retention targeting | 5/13</a:t>
+              <a:t>Retention Lab | Profit-aware churn &amp; retention targeting | 5/14</a:t>
             </a:r>
           </a:p>
         </p:txBody>
@@ -6476,7 +6911,7 @@
                 </a:solidFill>
                 <a:latin typeface="Segoe UI"/>
               </a:rPr>
-              <a:t>The decision rule</a:t>
+              <a:t>The list is fibre, month-to-month and high-bill</a:t>
             </a:r>
           </a:p>
         </p:txBody>
@@ -6489,42 +6924,8 @@
         </p:nvSpPr>
         <p:spPr>
           <a:xfrm>
-            <a:off x="502920" y="1051560"/>
-            <a:ext cx="11155680" cy="548640"/>
-          </a:xfrm>
-          <a:prstGeom prst="rect">
-            <a:avLst/>
-          </a:prstGeom>
-          <a:noFill/>
-        </p:spPr>
-        <p:txBody>
-          <a:bodyPr wrap="square">
-            <a:spAutoFit/>
-          </a:bodyPr>
-          <a:lstStyle/>
-          <a:p>
-            <a:r>
-              <a:rPr sz="1600" b="0">
-                <a:solidFill>
-                  <a:srgbClr val="52514E"/>
-                </a:solidFill>
-                <a:latin typeface="Segoe UI"/>
-              </a:rPr>
-              <a:t>Expected value = p(churn) x save rate x value - (offer + contact cost)</a:t>
-            </a:r>
-          </a:p>
-        </p:txBody>
-      </p:sp>
-      <p:sp>
-        <p:nvSpPr>
-          <p:cNvPr id="5" name="TextBox 4"/>
-          <p:cNvSpPr txBox="1"/>
-          <p:nvPr/>
-        </p:nvSpPr>
-        <p:spPr>
-          <a:xfrm>
-            <a:off x="502920" y="1645920"/>
-            <a:ext cx="11155680" cy="4754880"/>
+            <a:off x="502920" y="1143000"/>
+            <a:ext cx="4572000" cy="4754880"/>
           </a:xfrm>
           <a:prstGeom prst="rect">
             <a:avLst/>
@@ -6543,13 +6944,13 @@
               </a:spcAft>
             </a:pPr>
             <a:r>
-              <a:rPr sz="1800" b="0">
+              <a:rPr sz="1500" b="0">
                 <a:solidFill>
                   <a:srgbClr val="0B0B0B"/>
                 </a:solidFill>
                 <a:latin typeface="Segoe UI"/>
               </a:rPr>
-              <a:t>• Contact only customers with positive expected value</a:t>
+              <a:t>• 100% fibre and 97% monthly contracts, against 44% and 56% overall</a:t>
             </a:r>
           </a:p>
           <a:p>
@@ -6559,13 +6960,13 @@
               </a:spcAft>
             </a:pPr>
             <a:r>
-              <a:rPr sz="1800" b="0">
+              <a:rPr sz="1500" b="0">
                 <a:solidFill>
                   <a:srgbClr val="0B0B0B"/>
                 </a:solidFill>
                 <a:latin typeface="Segoe UI"/>
               </a:rPr>
-              <a:t>• Optimiser picks customer and offer within budget, one offer each, max 30% contacted</a:t>
+              <a:t>• Median bill $89 against $70</a:t>
             </a:r>
           </a:p>
           <a:p>
@@ -6575,13 +6976,13 @@
               </a:spcAft>
             </a:pPr>
             <a:r>
-              <a:rPr sz="1800" b="0">
+              <a:rPr sz="1500" b="0">
                 <a:solidFill>
                   <a:srgbClr val="0B0B0B"/>
                 </a:solidFill>
                 <a:latin typeface="Segoe UI"/>
               </a:rPr>
-              <a:t>• Four offers with eligibility rules: credit, contract upgrade, service bundle, loyalty reward</a:t>
+              <a:t>• No offer for low-risk customers: most would stay anyway</a:t>
             </a:r>
           </a:p>
           <a:p>
@@ -6591,17 +6992,41 @@
               </a:spcAft>
             </a:pPr>
             <a:r>
-              <a:rPr sz="1800" b="0">
+              <a:rPr sz="1500" b="0">
                 <a:solidFill>
                   <a:srgbClr val="0B0B0B"/>
                 </a:solidFill>
                 <a:latin typeface="Segoe UI"/>
               </a:rPr>
-              <a:t>• All costs and save rates are visible, sourced assumptions</a:t>
-            </a:r>
-          </a:p>
-        </p:txBody>
-      </p:sp>
+              <a:t>• Few offers for risky low-bill customers: their value cannot repay the offer</a:t>
+            </a:r>
+          </a:p>
+        </p:txBody>
+      </p:sp>
+      <p:pic>
+        <p:nvPicPr>
+          <p:cNvPr id="5" name="Picture 4" descr="target_profile.png"/>
+          <p:cNvPicPr>
+            <a:picLocks noChangeAspect="1"/>
+          </p:cNvPicPr>
+          <p:nvPr/>
+        </p:nvPicPr>
+        <p:blipFill>
+          <a:blip r:embed="rId2"/>
+          <a:stretch>
+            <a:fillRect/>
+          </a:stretch>
+        </p:blipFill>
+        <p:spPr>
+          <a:xfrm>
+            <a:off x="5303520" y="1143000"/>
+            <a:ext cx="6583680" cy="3218688"/>
+          </a:xfrm>
+          <a:prstGeom prst="rect">
+            <a:avLst/>
+          </a:prstGeom>
+        </p:spPr>
+      </p:pic>
       <p:sp>
         <p:nvSpPr>
           <p:cNvPr id="6" name="TextBox 5"/>
@@ -6631,7 +7056,7 @@
                 </a:solidFill>
                 <a:latin typeface="Segoe UI"/>
               </a:rPr>
-              <a:t>Retention Lab | Profit-aware churn &amp; retention targeting | 6/13</a:t>
+              <a:t>Retention Lab | Profit-aware churn &amp; retention targeting | 6/14</a:t>
             </a:r>
           </a:p>
         </p:txBody>
@@ -6765,7 +7190,7 @@
                 </a:solidFill>
                 <a:latin typeface="Segoe UI"/>
               </a:rPr>
-              <a:t>• Better targeting: +$1,032; with actual outcomes +$1,308 (95% CI $509 to $2,153)</a:t>
+              <a:t>• +$1,368 expected: $1,039 from who we target, $328 from which offer</a:t>
             </a:r>
           </a:p>
         </p:txBody>
@@ -6919,7 +7344,7 @@
                           </a:solidFill>
                           <a:latin typeface="Segoe UI"/>
                         </a:rPr>
-                        <a:t>Highest churn risk</a:t>
+                        <a:t>Highest churn risk (today)</a:t>
                       </a:r>
                     </a:p>
                   </a:txBody>
@@ -6955,7 +7380,7 @@
                           </a:solidFill>
                           <a:latin typeface="Segoe UI"/>
                         </a:rPr>
-                        <a:t>$1,098</a:t>
+                        <a:t>$1,301</a:t>
                       </a:r>
                     </a:p>
                   </a:txBody>
@@ -6973,7 +7398,7 @@
                           </a:solidFill>
                           <a:latin typeface="Segoe UI"/>
                         </a:rPr>
-                        <a:t>31%</a:t>
+                        <a:t>37%</a:t>
                       </a:r>
                     </a:p>
                   </a:txBody>
@@ -6991,7 +7416,7 @@
                           </a:solidFill>
                           <a:latin typeface="Segoe UI"/>
                         </a:rPr>
-                        <a:t>70%</a:t>
+                        <a:t>71%</a:t>
                       </a:r>
                     </a:p>
                   </a:txBody>
@@ -7009,7 +7434,7 @@
                           </a:solidFill>
                           <a:latin typeface="Segoe UI"/>
                         </a:rPr>
-                        <a:t>4%</a:t>
+                        <a:t>12%</a:t>
                       </a:r>
                     </a:p>
                   </a:txBody>
@@ -7029,7 +7454,7 @@
                           </a:solidFill>
                           <a:latin typeface="Segoe UI"/>
                         </a:rPr>
-                        <a:t>Expected value</a:t>
+                        <a:t>Expected value, one offer</a:t>
                       </a:r>
                     </a:p>
                   </a:txBody>
@@ -7065,7 +7490,7 @@
                           </a:solidFill>
                           <a:latin typeface="Segoe UI"/>
                         </a:rPr>
-                        <a:t>$2,130</a:t>
+                        <a:t>$2,340</a:t>
                       </a:r>
                     </a:p>
                   </a:txBody>
@@ -7083,7 +7508,7 @@
                           </a:solidFill>
                           <a:latin typeface="Segoe UI"/>
                         </a:rPr>
-                        <a:t>61%</a:t>
+                        <a:t>67%</a:t>
                       </a:r>
                     </a:p>
                   </a:txBody>
@@ -7101,7 +7526,7 @@
                           </a:solidFill>
                           <a:latin typeface="Segoe UI"/>
                         </a:rPr>
-                        <a:t>62%</a:t>
+                        <a:t>60%</a:t>
                       </a:r>
                     </a:p>
                   </a:txBody>
@@ -7139,7 +7564,7 @@
                           </a:solidFill>
                           <a:latin typeface="Segoe UI"/>
                         </a:rPr>
-                        <a:t>EV + segment offers</a:t>
+                        <a:t>Recommended: + segment offers</a:t>
                       </a:r>
                     </a:p>
                   </a:txBody>
@@ -7157,7 +7582,7 @@
                           </a:solidFill>
                           <a:latin typeface="Segoe UI"/>
                         </a:rPr>
-                        <a:t>152</a:t>
+                        <a:t>153</a:t>
                       </a:r>
                     </a:p>
                   </a:txBody>
@@ -7175,7 +7600,7 @@
                           </a:solidFill>
                           <a:latin typeface="Segoe UI"/>
                         </a:rPr>
-                        <a:t>$2,420</a:t>
+                        <a:t>$2,668</a:t>
                       </a:r>
                     </a:p>
                   </a:txBody>
@@ -7193,7 +7618,7 @@
                           </a:solidFill>
                           <a:latin typeface="Segoe UI"/>
                         </a:rPr>
-                        <a:t>69%</a:t>
+                        <a:t>76%</a:t>
                       </a:r>
                     </a:p>
                   </a:txBody>
@@ -7229,7 +7654,7 @@
                           </a:solidFill>
                           <a:latin typeface="Segoe UI"/>
                         </a:rPr>
-                        <a:t>100%</a:t>
+                        <a:t>98%</a:t>
                       </a:r>
                     </a:p>
                   </a:txBody>
@@ -7269,7 +7694,7 @@
                 </a:solidFill>
                 <a:latin typeface="Segoe UI"/>
               </a:rPr>
-              <a:t>Retention Lab | Profit-aware churn &amp; retention targeting | 7/13</a:t>
+              <a:t>Retention Lab | Profit-aware churn &amp; retention targeting | 7/14</a:t>
             </a:r>
           </a:p>
         </p:txBody>
@@ -7364,7 +7789,7 @@
                 </a:solidFill>
                 <a:latin typeface="Segoe UI"/>
               </a:rPr>
-              <a:t>How much to spend</a:t>
+              <a:t>Spend about $45,737 - then stop</a:t>
             </a:r>
           </a:p>
         </p:txBody>
@@ -7403,7 +7828,7 @@
                 </a:solidFill>
                 <a:latin typeface="Segoe UI"/>
               </a:rPr>
-              <a:t>• Recommended budget: $6.00 per customer in the base (chosen on validation)</a:t>
+              <a:t>• Each extra step reaches customers with less expected value</a:t>
             </a:r>
           </a:p>
           <a:p>
@@ -7419,7 +7844,7 @@
                 </a:solidFill>
                 <a:latin typeface="Segoe UI"/>
               </a:rPr>
-              <a:t>• Test: 310 offers (22% of customers), $8,450, net $3,692 (ROI 44%)</a:t>
+              <a:t>• Keep steps that return at least 10% (set on validation): $6.49 per customer</a:t>
             </a:r>
           </a:p>
           <a:p>
@@ -7435,7 +7860,23 @@
                 </a:solidFill>
                 <a:latin typeface="Segoe UI"/>
               </a:rPr>
-              <a:t>• Stop adding budget when the next step earns less than 10%</a:t>
+              <a:t>• Test customers: 324 offers, $9,150, net $4,145 (ROI 45%)</a:t>
+            </a:r>
+          </a:p>
+          <a:p>
+            <a:pPr>
+              <a:spcAft>
+                <a:spcPts val="800"/>
+              </a:spcAft>
+            </a:pPr>
+            <a:r>
+              <a:rPr sz="1500" b="0">
+                <a:solidFill>
+                  <a:srgbClr val="0B0B0B"/>
+                </a:solidFill>
+                <a:latin typeface="Segoe UI"/>
+              </a:rPr>
+              <a:t>• Beyond 26% of customers nobody is worth an offer</a:t>
             </a:r>
           </a:p>
         </p:txBody>
@@ -7493,7 +7934,7 @@
                 </a:solidFill>
                 <a:latin typeface="Segoe UI"/>
               </a:rPr>
-              <a:t>Retention Lab | Profit-aware churn &amp; retention targeting | 8/13</a:t>
+              <a:t>Retention Lab | Profit-aware churn &amp; retention targeting | 8/14</a:t>
             </a:r>
           </a:p>
         </p:txBody>
@@ -7588,7 +8029,7 @@
                 </a:solidFill>
                 <a:latin typeface="Segoe UI"/>
               </a:rPr>
-              <a:t>How robust is it?</a:t>
+              <a:t>Who to target is robust; how much an offer saves is not</a:t>
             </a:r>
           </a:p>
         </p:txBody>
@@ -7627,7 +8068,7 @@
                 </a:solidFill>
                 <a:latin typeface="Segoe UI"/>
               </a:rPr>
-              <a:t>• Break-even save rate 11.8% at the base budget, 13.9% at the recommended budget (assumed 20%)</a:t>
+              <a:t>• Break-even save rate: 11.3% (base list), 13.8% (recommended); assumed 20%</a:t>
             </a:r>
           </a:p>
           <a:p>
@@ -7643,7 +8084,7 @@
                 </a:solidFill>
                 <a:latin typeface="Segoe UI"/>
               </a:rPr>
-              <a:t>• Pessimistic $0 (no campaign) / base $2,420 / optimistic $18,525</a:t>
+              <a:t>• All assumptions uncertain: the recommended list loses money in 17% of draws</a:t>
             </a:r>
           </a:p>
           <a:p>
@@ -7659,14 +8100,30 @@
                 </a:solidFill>
                 <a:latin typeface="Segoe UI"/>
               </a:rPr>
-              <a:t>• Below 8.9% save rate: run no campaign</a:t>
+              <a:t>• Beats risk-only in 100% of draws</a:t>
+            </a:r>
+          </a:p>
+          <a:p>
+            <a:pPr>
+              <a:spcAft>
+                <a:spcPts val="800"/>
+              </a:spcAft>
+            </a:pPr>
+            <a:r>
+              <a:rPr sz="1500" b="0">
+                <a:solidFill>
+                  <a:srgbClr val="0B0B0B"/>
+                </a:solidFill>
+                <a:latin typeface="Segoe UI"/>
+              </a:rPr>
+              <a:t>• Only 46% of churners left for price or a competitor's offer</a:t>
             </a:r>
           </a:p>
         </p:txBody>
       </p:sp>
       <p:pic>
         <p:nvPicPr>
-          <p:cNvPr id="5" name="Picture 4" descr="tornado.png"/>
+          <p:cNvPr id="5" name="Picture 4" descr="monte_carlo.png"/>
           <p:cNvPicPr>
             <a:picLocks noChangeAspect="1"/>
           </p:cNvPicPr>
@@ -7681,7 +8138,7 @@
         <p:spPr>
           <a:xfrm>
             <a:off x="5303520" y="1143000"/>
-            <a:ext cx="6583680" cy="3326490"/>
+            <a:ext cx="6583680" cy="3364992"/>
           </a:xfrm>
           <a:prstGeom prst="rect">
             <a:avLst/>
@@ -7717,7 +8174,7 @@
                 </a:solidFill>
                 <a:latin typeface="Segoe UI"/>
               </a:rPr>
-              <a:t>Retention Lab | Profit-aware churn &amp; retention targeting | 9/13</a:t>
+              <a:t>Retention Lab | Profit-aware churn &amp; retention targeting | 9/14</a:t>
             </a:r>
           </a:p>
         </p:txBody>

</xml_diff>